<commit_message>
Slides: weeks 13 and 17 decks; ledger update
Co-Authored-By: Claude Opus 5.5 <noreply@anthropic.com>
Claude-Session: https://claude.ai/code/session_01XkzKv8pUGMF9AsqSCMpnBq
</commit_message>
<xml_diff>
--- a/slides/decks/s09-viral-infections-ptld.pptx
+++ b/slides/decks/s09-viral-infections-ptld.pptx
@@ -132,13 +132,13 @@
   <p:extLst>
     <p:ext uri="{521415D9-36F7-43E2-AB2F-B90AF26B5E84}">
       <p14:sectionLst xmlns:p14="http://schemas.microsoft.com/office/powerpoint/2010/main">
-        <p14:section name="Opening" id="{dc12d70d-3839-f5e6-5eab-364786df788a}">
+        <p14:section name="Opening" id="{bd55f980-b497-b4fe-c812-546a1d74fd49}">
           <p14:sldIdLst>
             <p14:sldId id="256"/>
             <p14:sldId id="257"/>
           </p14:sldIdLst>
         </p14:section>
-        <p14:section name="CMV" id="{fe77e7f8-ac86-1f4d-cc0f-6104b7520cae}">
+        <p14:section name="CMV" id="{ab45a429-b220-17ec-913a-e01cecb89c0d}">
           <p14:sldIdLst>
             <p14:sldId id="258"/>
             <p14:sldId id="259"/>
@@ -146,7 +146,7 @@
             <p14:sldId id="261"/>
           </p14:sldIdLst>
         </p14:section>
-        <p14:section name="Other viruses" id="{99cdf192-1e11-7209-c5fd-5a0cda123067}">
+        <p14:section name="Other viruses" id="{8135b0da-f405-71ed-ce8f-55a1290ef0a4}">
           <p14:sldIdLst>
             <p14:sldId id="262"/>
             <p14:sldId id="263"/>
@@ -155,7 +155,7 @@
             <p14:sldId id="266"/>
           </p14:sldIdLst>
         </p14:section>
-        <p14:section name="EBV and PTLD" id="{743bf346-0dfc-7990-0c25-00f0a620e6a3}">
+        <p14:section name="EBV and PTLD" id="{06339fa7-9366-6443-2be9-45ced8b6ea5a}">
           <p14:sldIdLst>
             <p14:sldId id="267"/>
             <p14:sldId id="268"/>
@@ -163,12 +163,12 @@
             <p14:sldId id="270"/>
           </p14:sldIdLst>
         </p14:section>
-        <p14:section name="Other infections" id="{b13cc9ef-73ff-514b-8544-6bf8fea62a35}">
+        <p14:section name="Other infections" id="{adb79aaa-d859-a896-d827-17758cb0b6fd}">
           <p14:sldIdLst>
             <p14:sldId id="271"/>
           </p14:sldIdLst>
         </p14:section>
-        <p14:section name="Board questions" id="{407cc251-ac0f-d5a9-5d33-67f0550a0a54}">
+        <p14:section name="Board questions" id="{c4924b91-5a61-a8e5-3950-d9b7262038c3}">
           <p14:sldIdLst>
             <p14:sldId id="272"/>
             <p14:sldId id="273"/>
@@ -178,12 +178,12 @@
             <p14:sldId id="277"/>
           </p14:sldIdLst>
         </p14:section>
-        <p14:section name="References" id="{fa50e2e5-d74b-acfd-3f77-589f0fbb368e}">
+        <p14:section name="References" id="{c866e093-6b78-b469-42c8-d96890898a6c}">
           <p14:sldIdLst>
             <p14:sldId id="278"/>
           </p14:sldIdLst>
         </p14:section>
-        <p14:section name="Backup" id="{277b5471-42e9-67f6-53d1-5953b80d03fb}">
+        <p14:section name="Backup" id="{d2eb8064-6c61-036c-00d3-a20714fbfaa4}">
           <p14:sldIdLst>
             <p14:sldId id="279"/>
             <p14:sldId id="280"/>
@@ -9055,7 +9055,21 @@
                   <a:schemeClr val="tx1"/>
                 </a:solidFill>
               </a:rPr>
-              <a:t>Rituximab weekly (1–2 doses) + RIS</a:t>
+              <a:t>Rituximab weekly,</a:t>
+            </a:r>
+            <a:endParaRPr lang="en-US" sz="1500" dirty="0"/>
+          </a:p>
+          <a:p>
+            <a:pPr algn="ctr" indent="0" marL="0">
+              <a:buNone/>
+            </a:pPr>
+            <a:r>
+              <a:rPr lang="en-US" sz="1500" dirty="0">
+                <a:solidFill>
+                  <a:schemeClr val="tx1"/>
+                </a:solidFill>
+              </a:rPr>
+              <a:t>1–2 doses, + RIS</a:t>
             </a:r>
             <a:endParaRPr lang="en-US" sz="1500" dirty="0"/>
           </a:p>
@@ -17690,7 +17704,7 @@
                   <a:schemeClr val="bg1"/>
                 </a:solidFill>
               </a:rPr>
-              <a:t>Letermovir 3 months if CMV+</a:t>
+              <a:t>Letermovir 3 months if CMV+</a:t>
             </a:r>
             <a:endParaRPr lang="en-US" sz="1500" dirty="0"/>
           </a:p>

</xml_diff>

<commit_message>
Slides: week 5 GVHD prophylaxis deck; ledger update
Co-Authored-By: Claude Opus 5.5 <noreply@anthropic.com>
Claude-Session: https://claude.ai/code/session_01XkzKv8pUGMF9AsqSCMpnBq
</commit_message>
<xml_diff>
--- a/slides/decks/s09-viral-infections-ptld.pptx
+++ b/slides/decks/s09-viral-infections-ptld.pptx
@@ -132,13 +132,13 @@
   <p:extLst>
     <p:ext uri="{521415D9-36F7-43E2-AB2F-B90AF26B5E84}">
       <p14:sectionLst xmlns:p14="http://schemas.microsoft.com/office/powerpoint/2010/main">
-        <p14:section name="Opening" id="{bd55f980-b497-b4fe-c812-546a1d74fd49}">
+        <p14:section name="Opening" id="{60785a16-60be-33d8-5d13-2e609c8b1d35}">
           <p14:sldIdLst>
             <p14:sldId id="256"/>
             <p14:sldId id="257"/>
           </p14:sldIdLst>
         </p14:section>
-        <p14:section name="CMV" id="{ab45a429-b220-17ec-913a-e01cecb89c0d}">
+        <p14:section name="CMV" id="{ac13f643-6ed6-bed6-8cdc-c9bc722ba936}">
           <p14:sldIdLst>
             <p14:sldId id="258"/>
             <p14:sldId id="259"/>
@@ -146,7 +146,7 @@
             <p14:sldId id="261"/>
           </p14:sldIdLst>
         </p14:section>
-        <p14:section name="Other viruses" id="{8135b0da-f405-71ed-ce8f-55a1290ef0a4}">
+        <p14:section name="Other viruses" id="{a5240a5f-0556-35ba-4e5c-151bc1ffbe22}">
           <p14:sldIdLst>
             <p14:sldId id="262"/>
             <p14:sldId id="263"/>
@@ -155,7 +155,7 @@
             <p14:sldId id="266"/>
           </p14:sldIdLst>
         </p14:section>
-        <p14:section name="EBV and PTLD" id="{06339fa7-9366-6443-2be9-45ced8b6ea5a}">
+        <p14:section name="EBV and PTLD" id="{ac3d861e-6427-0f87-75f1-33b715100293}">
           <p14:sldIdLst>
             <p14:sldId id="267"/>
             <p14:sldId id="268"/>
@@ -163,12 +163,12 @@
             <p14:sldId id="270"/>
           </p14:sldIdLst>
         </p14:section>
-        <p14:section name="Other infections" id="{adb79aaa-d859-a896-d827-17758cb0b6fd}">
+        <p14:section name="Other infections" id="{ebe6e288-c37f-1ba1-6332-b5c4b6e235c1}">
           <p14:sldIdLst>
             <p14:sldId id="271"/>
           </p14:sldIdLst>
         </p14:section>
-        <p14:section name="Board questions" id="{c4924b91-5a61-a8e5-3950-d9b7262038c3}">
+        <p14:section name="Board questions" id="{17fb8a7a-d974-338a-6259-18c0a633fb45}">
           <p14:sldIdLst>
             <p14:sldId id="272"/>
             <p14:sldId id="273"/>
@@ -178,12 +178,12 @@
             <p14:sldId id="277"/>
           </p14:sldIdLst>
         </p14:section>
-        <p14:section name="References" id="{c866e093-6b78-b469-42c8-d96890898a6c}">
+        <p14:section name="References" id="{263f2812-026d-9789-6ecd-9d48d9879a6b}">
           <p14:sldIdLst>
             <p14:sldId id="278"/>
           </p14:sldIdLst>
         </p14:section>
-        <p14:section name="Backup" id="{d2eb8064-6c61-036c-00d3-a20714fbfaa4}">
+        <p14:section name="Backup" id="{6543790f-bd16-0018-8e62-3b2e1a758340}">
           <p14:sldIdLst>
             <p14:sldId id="279"/>
             <p14:sldId id="280"/>
@@ -5816,7 +5816,7 @@
                   <a:schemeClr val="tx1"/>
                 </a:solidFill>
               </a:rPr>
-              <a:t>Adenovirus is monitored by risk and treated with cidofovir</a:t>
+              <a:t>Adenovirus is monitored by risk and treated preemptively with cidofovir</a:t>
             </a:r>
             <a:endParaRPr lang="en-US" sz="3600" dirty="0"/>
           </a:p>
@@ -8589,7 +8589,7 @@
                   <a:schemeClr val="tx1"/>
                 </a:solidFill>
               </a:rPr>
-              <a:t>EBV management escalates from prophylaxis to treatment</a:t>
+              <a:t>EBV management moves from prophylaxis to preemption to treatment</a:t>
             </a:r>
             <a:endParaRPr lang="en-US" sz="3600" dirty="0"/>
           </a:p>
@@ -10630,7 +10630,7 @@
                   <a:schemeClr val="tx1"/>
                 </a:solidFill>
               </a:rPr>
-              <a:t>Rare non-viral infections cluster in patients with GVHD</a:t>
+              <a:t>Rare non-viral infections cluster in patients with GVHD on steroids</a:t>
             </a:r>
             <a:endParaRPr lang="en-US" sz="3600" dirty="0"/>
           </a:p>
@@ -13767,7 +13767,7 @@
                   <a:schemeClr val="tx1"/>
                 </a:solidFill>
               </a:rPr>
-              <a:t>Answer B: rituximab plus reduced immunosuppression</a:t>
+              <a:t>Answer B: rituximab plus RIS</a:t>
             </a:r>
             <a:endParaRPr lang="en-US" sz="3600" dirty="0"/>
           </a:p>
@@ -13819,7 +13819,7 @@
         </p:nvSpPr>
         <p:spPr>
           <a:xfrm>
-            <a:off x="685800" y="2240280"/>
+            <a:off x="685800" y="1783080"/>
             <a:ext cx="10817352" cy="731520"/>
           </a:xfrm>
           <a:prstGeom prst="rect">
@@ -13861,8 +13861,8 @@
         </p:nvSpPr>
         <p:spPr>
           <a:xfrm>
-            <a:off x="685800" y="3246120"/>
-            <a:ext cx="10817352" cy="2651760"/>
+            <a:off x="685800" y="2788920"/>
+            <a:ext cx="10817352" cy="3108960"/>
           </a:xfrm>
           <a:prstGeom prst="rect">
             <a:avLst/>
@@ -14356,7 +14356,7 @@
                   <a:schemeClr val="tx1"/>
                 </a:solidFill>
               </a:rPr>
-              <a:t>Answer A: image the brain in every pulmonary nocardiosis</a:t>
+              <a:t>Answer A: always image the brain</a:t>
             </a:r>
             <a:endParaRPr lang="en-US" sz="3600" dirty="0"/>
           </a:p>
@@ -14408,7 +14408,7 @@
         </p:nvSpPr>
         <p:spPr>
           <a:xfrm>
-            <a:off x="685800" y="2240280"/>
+            <a:off x="685800" y="1783080"/>
             <a:ext cx="10817352" cy="731520"/>
           </a:xfrm>
           <a:prstGeom prst="rect">
@@ -14450,8 +14450,8 @@
         </p:nvSpPr>
         <p:spPr>
           <a:xfrm>
-            <a:off x="685800" y="3246120"/>
-            <a:ext cx="10817352" cy="2651760"/>
+            <a:off x="685800" y="2788920"/>
+            <a:ext cx="10817352" cy="3108960"/>
           </a:xfrm>
           <a:prstGeom prst="rect">
             <a:avLst/>
@@ -15856,7 +15856,7 @@
                   <a:schemeClr val="tx1"/>
                 </a:solidFill>
               </a:rPr>
-              <a:t>CNS PTLD and response criteria follow their own rules</a:t>
+              <a:t>CNS PTLD lacks a standard; response is judged by EBV DNA and imaging</a:t>
             </a:r>
             <a:endParaRPr lang="en-US" sz="3600" dirty="0"/>
           </a:p>
@@ -16656,7 +16656,7 @@
                   <a:schemeClr val="tx1"/>
                 </a:solidFill>
               </a:rPr>
-              <a:t>Toxoplasmosis needs full-dose TMP/SMX prophylaxis</a:t>
+              <a:t>TMP/SMX below 3 days a week lets toxoplasmosis break through</a:t>
             </a:r>
             <a:endParaRPr lang="en-US" sz="3600" dirty="0"/>
           </a:p>
@@ -18018,7 +18018,7 @@
                   <a:schemeClr val="tx1"/>
                 </a:solidFill>
               </a:rPr>
-              <a:t>Letermovir prophylaxis cuts CMV infection and mortality</a:t>
+              <a:t>Letermovir prophylaxis lowers CMV infection and all-cause mortality</a:t>
             </a:r>
             <a:endParaRPr lang="en-US" sz="3600" dirty="0"/>
           </a:p>
@@ -20923,7 +20923,7 @@
                   <a:schemeClr val="tx1"/>
                 </a:solidFill>
               </a:rPr>
-              <a:t>Acyclovir dosing depends on indication and severity</a:t>
+              <a:t>Acyclovir dosing depends on the indication and on disease severity</a:t>
             </a:r>
             <a:endParaRPr lang="en-US" sz="3600" dirty="0"/>
           </a:p>

</xml_diff>

<commit_message>
Slides: weeks 9 and 12 in progress
Co-Authored-By: Claude Opus 5.5 <noreply@anthropic.com>
Claude-Session: https://claude.ai/code/session_01XkzKv8pUGMF9AsqSCMpnBq
</commit_message>
<xml_diff>
--- a/slides/decks/s09-viral-infections-ptld.pptx
+++ b/slides/decks/s09-viral-infections-ptld.pptx
@@ -132,13 +132,13 @@
   <p:extLst>
     <p:ext uri="{521415D9-36F7-43E2-AB2F-B90AF26B5E84}">
       <p14:sectionLst xmlns:p14="http://schemas.microsoft.com/office/powerpoint/2010/main">
-        <p14:section name="Opening" id="{60785a16-60be-33d8-5d13-2e609c8b1d35}">
+        <p14:section name="Opening" id="{8e103630-2409-15f8-3ebb-2c8dbfdf169b}">
           <p14:sldIdLst>
             <p14:sldId id="256"/>
             <p14:sldId id="257"/>
           </p14:sldIdLst>
         </p14:section>
-        <p14:section name="CMV" id="{ac13f643-6ed6-bed6-8cdc-c9bc722ba936}">
+        <p14:section name="CMV" id="{03b5d123-9d47-a750-9c2a-6b61f563eead}">
           <p14:sldIdLst>
             <p14:sldId id="258"/>
             <p14:sldId id="259"/>
@@ -146,7 +146,7 @@
             <p14:sldId id="261"/>
           </p14:sldIdLst>
         </p14:section>
-        <p14:section name="Other viruses" id="{a5240a5f-0556-35ba-4e5c-151bc1ffbe22}">
+        <p14:section name="Other viruses" id="{abf3858c-29a3-56cd-e47d-6e2b6ab84601}">
           <p14:sldIdLst>
             <p14:sldId id="262"/>
             <p14:sldId id="263"/>
@@ -155,7 +155,7 @@
             <p14:sldId id="266"/>
           </p14:sldIdLst>
         </p14:section>
-        <p14:section name="EBV and PTLD" id="{ac3d861e-6427-0f87-75f1-33b715100293}">
+        <p14:section name="EBV and PTLD" id="{c9d7b123-55dc-a8ee-d180-1e4d6f541923}">
           <p14:sldIdLst>
             <p14:sldId id="267"/>
             <p14:sldId id="268"/>
@@ -163,12 +163,12 @@
             <p14:sldId id="270"/>
           </p14:sldIdLst>
         </p14:section>
-        <p14:section name="Other infections" id="{ebe6e288-c37f-1ba1-6332-b5c4b6e235c1}">
+        <p14:section name="Other infections" id="{b8b946ca-ea3b-fc66-bcb2-e3f3a81bf29b}">
           <p14:sldIdLst>
             <p14:sldId id="271"/>
           </p14:sldIdLst>
         </p14:section>
-        <p14:section name="Board questions" id="{17fb8a7a-d974-338a-6259-18c0a633fb45}">
+        <p14:section name="Board questions" id="{b40bab98-7aeb-7751-e302-37831d895dda}">
           <p14:sldIdLst>
             <p14:sldId id="272"/>
             <p14:sldId id="273"/>
@@ -178,12 +178,12 @@
             <p14:sldId id="277"/>
           </p14:sldIdLst>
         </p14:section>
-        <p14:section name="References" id="{263f2812-026d-9789-6ecd-9d48d9879a6b}">
+        <p14:section name="References" id="{93ed5af8-dd11-cd54-b15d-dfeec6c02a36}">
           <p14:sldIdLst>
             <p14:sldId id="278"/>
           </p14:sldIdLst>
         </p14:section>
-        <p14:section name="Backup" id="{6543790f-bd16-0018-8e62-3b2e1a758340}">
+        <p14:section name="Backup" id="{4a375ba2-40b4-4962-f6e9-7f074a5f20b8}">
           <p14:sldIdLst>
             <p14:sldId id="279"/>
             <p14:sldId id="280"/>
@@ -13883,7 +13883,7 @@
                   <a:schemeClr val="tx1"/>
                 </a:solidFill>
               </a:rPr>
-              <a:t>Symptoms plus EBER-ISH in tissue = proven EBV-PTLD; treat at once. First line: rituximab 375 mg/m² weekly, with RIS unless GVHD is severe and uncontrolled, or EBV-CTL if available. Response: rituximab 65%, with RIS 78%. Chemotherapy ± rituximab is second line; antivirals, IVIG and interferon should not be used.</a:t>
+              <a:t>Symptoms plus EBER-ISH in tissue = proven EBV-PTLD; treat at once. First line: rituximab 375 mg/m² weekly, with RIS unless GVHD is severe and uncontrolled, or EBV-CTL if available. Response: rituximab 65%, with RIS 78%. Chemotherapy ± rituximab is second line. Antivirals, IVIG and interferon have no role.</a:t>
             </a:r>
             <a:endParaRPr lang="en-US" sz="1800" dirty="0"/>
           </a:p>

</xml_diff>